<commit_message>
memberikan tambahan coment yang lebih informatif dan update PPT
</commit_message>
<xml_diff>
--- a/PPT PRESENTASI TUGAS BESAR.pptx
+++ b/PPT PRESENTASI TUGAS BESAR.pptx
@@ -5,7 +5,7 @@
     <p:sldMasterId id="2147483648" r:id="rId1"/>
   </p:sldMasterIdLst>
   <p:notesMasterIdLst>
-    <p:notesMasterId r:id="rId12"/>
+    <p:notesMasterId r:id="rId13"/>
   </p:notesMasterIdLst>
   <p:sldIdLst>
     <p:sldId id="256" r:id="rId2"/>
@@ -13,23 +13,24 @@
     <p:sldId id="258" r:id="rId4"/>
     <p:sldId id="259" r:id="rId5"/>
     <p:sldId id="260" r:id="rId6"/>
-    <p:sldId id="261" r:id="rId7"/>
-    <p:sldId id="262" r:id="rId8"/>
-    <p:sldId id="263" r:id="rId9"/>
-    <p:sldId id="264" r:id="rId10"/>
-    <p:sldId id="265" r:id="rId11"/>
+    <p:sldId id="266" r:id="rId7"/>
+    <p:sldId id="261" r:id="rId8"/>
+    <p:sldId id="262" r:id="rId9"/>
+    <p:sldId id="263" r:id="rId10"/>
+    <p:sldId id="264" r:id="rId11"/>
+    <p:sldId id="265" r:id="rId12"/>
   </p:sldIdLst>
   <p:sldSz cx="14630400" cy="8229600"/>
   <p:notesSz cx="8229600" cy="14630400"/>
   <p:embeddedFontLst>
     <p:embeddedFont>
       <p:font typeface="Inconsolata" pitchFamily="1" charset="0"/>
-      <p:regular r:id="rId13"/>
+      <p:regular r:id="rId14"/>
     </p:embeddedFont>
     <p:embeddedFont>
       <p:font typeface="Montserrat Black" panose="00000A00000000000000" pitchFamily="2" charset="0"/>
-      <p:regular r:id="rId14"/>
-      <p:bold r:id="rId15"/>
+      <p:regular r:id="rId15"/>
+      <p:bold r:id="rId16"/>
     </p:embeddedFont>
   </p:embeddedFontLst>
   <p:defaultTextStyle>
@@ -428,6 +429,90 @@
 </p:notes>
 </file>
 
+<file path=ppt/notesSlides/notesSlide11.xml><?xml version="1.0" encoding="utf-8"?>
+<p:notes xmlns:a="http://schemas.openxmlformats.org/drawingml/2006/main" xmlns:r="http://schemas.openxmlformats.org/officeDocument/2006/relationships" xmlns:p="http://schemas.openxmlformats.org/presentationml/2006/main">
+  <p:cSld>
+    <p:spTree>
+      <p:nvGrpSpPr>
+        <p:cNvPr id="1" name=""/>
+        <p:cNvGrpSpPr/>
+        <p:nvPr/>
+      </p:nvGrpSpPr>
+      <p:grpSpPr>
+        <a:xfrm>
+          <a:off x="0" y="0"/>
+          <a:ext cx="0" cy="0"/>
+          <a:chOff x="0" y="0"/>
+          <a:chExt cx="0" cy="0"/>
+        </a:xfrm>
+      </p:grpSpPr>
+      <p:sp>
+        <p:nvSpPr>
+          <p:cNvPr id="2" name="Slide Image Placeholder 1"/>
+          <p:cNvSpPr>
+            <a:spLocks noGrp="1" noRot="1" noChangeAspect="1"/>
+          </p:cNvSpPr>
+          <p:nvPr>
+            <p:ph type="sldImg"/>
+          </p:nvPr>
+        </p:nvSpPr>
+        <p:spPr/>
+      </p:sp>
+      <p:sp>
+        <p:nvSpPr>
+          <p:cNvPr id="3" name="Notes Placeholder 2"/>
+          <p:cNvSpPr>
+            <a:spLocks noGrp="1"/>
+          </p:cNvSpPr>
+          <p:nvPr>
+            <p:ph type="body" idx="1"/>
+          </p:nvPr>
+        </p:nvSpPr>
+        <p:spPr/>
+        <p:txBody>
+          <a:bodyPr/>
+          <a:lstStyle/>
+          <a:p>
+            <a:endParaRPr lang="en-US" dirty="0"/>
+          </a:p>
+        </p:txBody>
+      </p:sp>
+      <p:sp>
+        <p:nvSpPr>
+          <p:cNvPr id="4" name="Slide Number Placeholder 3"/>
+          <p:cNvSpPr>
+            <a:spLocks noGrp="1"/>
+          </p:cNvSpPr>
+          <p:nvPr>
+            <p:ph type="sldNum" sz="quarter" idx="10"/>
+          </p:nvPr>
+        </p:nvSpPr>
+        <p:spPr/>
+        <p:txBody>
+          <a:bodyPr/>
+          <a:lstStyle/>
+          <a:p>
+            <a:fld id="{F7021451-1387-4CA6-816F-3879F97B5CBC}" type="slidenum">
+              <a:rPr lang="en-US"/>
+              <a:t>11</a:t>
+            </a:fld>
+            <a:endParaRPr lang="en-US"/>
+          </a:p>
+        </p:txBody>
+      </p:sp>
+    </p:spTree>
+    <p:extLst>
+      <p:ext uri="{BB962C8B-B14F-4D97-AF65-F5344CB8AC3E}">
+        <p14:creationId xmlns:p14="http://schemas.microsoft.com/office/powerpoint/2010/main" val="1024086991"/>
+      </p:ext>
+    </p:extLst>
+  </p:cSld>
+  <p:clrMapOvr>
+    <a:masterClrMapping/>
+  </p:clrMapOvr>
+</p:notes>
+</file>
+
 <file path=ppt/notesSlides/notesSlide2.xml><?xml version="1.0" encoding="utf-8"?>
 <p:notes xmlns:a="http://schemas.openxmlformats.org/drawingml/2006/main" xmlns:r="http://schemas.openxmlformats.org/officeDocument/2006/relationships" xmlns:p="http://schemas.openxmlformats.org/presentationml/2006/main">
   <p:cSld>
@@ -769,7 +854,13 @@
   <p:cSld>
     <p:spTree>
       <p:nvGrpSpPr>
-        <p:cNvPr id="1" name=""/>
+        <p:cNvPr id="1" name="">
+          <a:extLst>
+            <a:ext uri="{FF2B5EF4-FFF2-40B4-BE49-F238E27FC236}">
+              <a16:creationId xmlns:a16="http://schemas.microsoft.com/office/drawing/2014/main" id="{E65F0545-4942-1372-1232-A435B5F818DB}"/>
+            </a:ext>
+          </a:extLst>
+        </p:cNvPr>
         <p:cNvGrpSpPr/>
         <p:nvPr/>
       </p:nvGrpSpPr>
@@ -783,7 +874,13 @@
       </p:grpSpPr>
       <p:sp>
         <p:nvSpPr>
-          <p:cNvPr id="2" name="Slide Image Placeholder 1"/>
+          <p:cNvPr id="2" name="Slide Image Placeholder 1">
+            <a:extLst>
+              <a:ext uri="{FF2B5EF4-FFF2-40B4-BE49-F238E27FC236}">
+                <a16:creationId xmlns:a16="http://schemas.microsoft.com/office/drawing/2014/main" id="{295766E4-26E1-7A0B-E759-1B960A4F62F8}"/>
+              </a:ext>
+            </a:extLst>
+          </p:cNvPr>
           <p:cNvSpPr>
             <a:spLocks noGrp="1" noRot="1" noChangeAspect="1"/>
           </p:cNvSpPr>
@@ -795,7 +892,13 @@
       </p:sp>
       <p:sp>
         <p:nvSpPr>
-          <p:cNvPr id="3" name="Notes Placeholder 2"/>
+          <p:cNvPr id="3" name="Notes Placeholder 2">
+            <a:extLst>
+              <a:ext uri="{FF2B5EF4-FFF2-40B4-BE49-F238E27FC236}">
+                <a16:creationId xmlns:a16="http://schemas.microsoft.com/office/drawing/2014/main" id="{45FF53CB-66E4-E09C-CE40-9F566426BCE3}"/>
+              </a:ext>
+            </a:extLst>
+          </p:cNvPr>
           <p:cNvSpPr>
             <a:spLocks noGrp="1"/>
           </p:cNvSpPr>
@@ -814,7 +917,13 @@
       </p:sp>
       <p:sp>
         <p:nvSpPr>
-          <p:cNvPr id="4" name="Slide Number Placeholder 3"/>
+          <p:cNvPr id="4" name="Slide Number Placeholder 3">
+            <a:extLst>
+              <a:ext uri="{FF2B5EF4-FFF2-40B4-BE49-F238E27FC236}">
+                <a16:creationId xmlns:a16="http://schemas.microsoft.com/office/drawing/2014/main" id="{BDAB881E-6ABF-AD0C-01F0-A79544AEB6D7}"/>
+              </a:ext>
+            </a:extLst>
+          </p:cNvPr>
           <p:cNvSpPr>
             <a:spLocks noGrp="1"/>
           </p:cNvSpPr>
@@ -838,7 +947,7 @@
     </p:spTree>
     <p:extLst>
       <p:ext uri="{BB962C8B-B14F-4D97-AF65-F5344CB8AC3E}">
-        <p14:creationId xmlns:p14="http://schemas.microsoft.com/office/powerpoint/2010/main" val="1024086991"/>
+        <p14:creationId xmlns:p14="http://schemas.microsoft.com/office/powerpoint/2010/main" val="625713935"/>
       </p:ext>
     </p:extLst>
   </p:cSld>
@@ -2744,6 +2853,464 @@
 
 <file path=ppt/slides/slide10.xml><?xml version="1.0" encoding="utf-8"?>
 <p:sld xmlns:a="http://schemas.openxmlformats.org/drawingml/2006/main" xmlns:r="http://schemas.openxmlformats.org/officeDocument/2006/relationships" xmlns:p="http://schemas.openxmlformats.org/presentationml/2006/main">
+  <p:cSld name="Slide 9">
+    <p:spTree>
+      <p:nvGrpSpPr>
+        <p:cNvPr id="1" name=""/>
+        <p:cNvGrpSpPr/>
+        <p:nvPr/>
+      </p:nvGrpSpPr>
+      <p:grpSpPr>
+        <a:xfrm>
+          <a:off x="0" y="0"/>
+          <a:ext cx="0" cy="0"/>
+          <a:chOff x="0" y="0"/>
+          <a:chExt cx="0" cy="0"/>
+        </a:xfrm>
+      </p:grpSpPr>
+      <p:sp>
+        <p:nvSpPr>
+          <p:cNvPr id="2" name="Text 0"/>
+          <p:cNvSpPr/>
+          <p:nvPr/>
+        </p:nvSpPr>
+        <p:spPr>
+          <a:xfrm>
+            <a:off x="793790" y="1309162"/>
+            <a:ext cx="5795367" cy="496133"/>
+          </a:xfrm>
+          <a:prstGeom prst="rect">
+            <a:avLst/>
+          </a:prstGeom>
+          <a:noFill/>
+          <a:ln/>
+        </p:spPr>
+        <p:txBody>
+          <a:bodyPr wrap="none" lIns="0" tIns="0" rIns="0" bIns="0" rtlCol="0" anchor="t"/>
+          <a:lstStyle/>
+          <a:p>
+            <a:pPr marL="0" indent="0" algn="l">
+              <a:lnSpc>
+                <a:spcPts val="3900"/>
+              </a:lnSpc>
+              <a:buNone/>
+            </a:pPr>
+            <a:r>
+              <a:rPr lang="en-US" sz="3100" b="1" dirty="0">
+                <a:solidFill>
+                  <a:srgbClr val="151617"/>
+                </a:solidFill>
+                <a:latin typeface="Montserrat Black" pitchFamily="34" charset="0"/>
+                <a:ea typeface="Montserrat Black" pitchFamily="34" charset="-122"/>
+                <a:cs typeface="Montserrat Black" pitchFamily="34" charset="-120"/>
+              </a:rPr>
+              <a:t>Teknologi yang Digunakan</a:t>
+            </a:r>
+            <a:endParaRPr lang="en-US" sz="3100" dirty="0"/>
+          </a:p>
+        </p:txBody>
+      </p:sp>
+      <p:sp>
+        <p:nvSpPr>
+          <p:cNvPr id="3" name="Text 1"/>
+          <p:cNvSpPr/>
+          <p:nvPr/>
+        </p:nvSpPr>
+        <p:spPr>
+          <a:xfrm>
+            <a:off x="603315" y="2200822"/>
+            <a:ext cx="13129601" cy="3802410"/>
+          </a:xfrm>
+          <a:prstGeom prst="rect">
+            <a:avLst/>
+          </a:prstGeom>
+          <a:noFill/>
+          <a:ln/>
+        </p:spPr>
+        <p:txBody>
+          <a:bodyPr wrap="square" lIns="0" tIns="0" rIns="0" bIns="0" rtlCol="0" anchor="t"/>
+          <a:lstStyle/>
+          <a:p>
+            <a:pPr marL="342900" indent="-342900" algn="l">
+              <a:lnSpc>
+                <a:spcPts val="2500"/>
+              </a:lnSpc>
+              <a:buSzPct val="100000"/>
+              <a:buChar char="•"/>
+            </a:pPr>
+            <a:r>
+              <a:rPr lang="en-US" sz="2800" dirty="0">
+                <a:solidFill>
+                  <a:srgbClr val="151617"/>
+                </a:solidFill>
+                <a:latin typeface="Inconsolata" pitchFamily="34" charset="0"/>
+                <a:ea typeface="Inconsolata" pitchFamily="34" charset="-122"/>
+                <a:cs typeface="Inconsolata" pitchFamily="34" charset="-120"/>
+              </a:rPr>
+              <a:t>Backend: PHP (OOP) — struktur rapi, mudah dipelajari untuk siswa yang baru </a:t>
+            </a:r>
+            <a:r>
+              <a:rPr lang="en-US" sz="2800" dirty="0" err="1">
+                <a:solidFill>
+                  <a:srgbClr val="151617"/>
+                </a:solidFill>
+                <a:latin typeface="Inconsolata" pitchFamily="34" charset="0"/>
+                <a:ea typeface="Inconsolata" pitchFamily="34" charset="-122"/>
+                <a:cs typeface="Inconsolata" pitchFamily="34" charset="-120"/>
+              </a:rPr>
+              <a:t>belajar</a:t>
+            </a:r>
+            <a:r>
+              <a:rPr lang="en-US" sz="2800" dirty="0">
+                <a:solidFill>
+                  <a:srgbClr val="151617"/>
+                </a:solidFill>
+                <a:latin typeface="Inconsolata" pitchFamily="34" charset="0"/>
+                <a:ea typeface="Inconsolata" pitchFamily="34" charset="-122"/>
+                <a:cs typeface="Inconsolata" pitchFamily="34" charset="-120"/>
+              </a:rPr>
+              <a:t>.</a:t>
+            </a:r>
+          </a:p>
+          <a:p>
+            <a:pPr marL="342900" indent="-342900" algn="l">
+              <a:lnSpc>
+                <a:spcPts val="2500"/>
+              </a:lnSpc>
+              <a:buSzPct val="100000"/>
+              <a:buChar char="•"/>
+            </a:pPr>
+            <a:endParaRPr lang="en-US" sz="2800" dirty="0"/>
+          </a:p>
+          <a:p>
+            <a:pPr marL="342900" indent="-342900" algn="l">
+              <a:lnSpc>
+                <a:spcPts val="2500"/>
+              </a:lnSpc>
+              <a:buSzPct val="100000"/>
+              <a:buChar char="•"/>
+            </a:pPr>
+            <a:r>
+              <a:rPr lang="en-US" sz="2800" dirty="0">
+                <a:solidFill>
+                  <a:srgbClr val="151617"/>
+                </a:solidFill>
+                <a:latin typeface="Inconsolata" pitchFamily="34" charset="0"/>
+                <a:ea typeface="Inconsolata" pitchFamily="34" charset="-122"/>
+                <a:cs typeface="Inconsolata" pitchFamily="34" charset="-120"/>
+              </a:rPr>
+              <a:t>Arsitektur: MVC (Model-View-Controller) — memisahkan logika, tampilan, dan data.</a:t>
+            </a:r>
+          </a:p>
+          <a:p>
+            <a:pPr marL="342900" indent="-342900" algn="l">
+              <a:lnSpc>
+                <a:spcPts val="2500"/>
+              </a:lnSpc>
+              <a:buSzPct val="100000"/>
+              <a:buChar char="•"/>
+            </a:pPr>
+            <a:endParaRPr lang="en-US" sz="2800" dirty="0"/>
+          </a:p>
+          <a:p>
+            <a:pPr marL="342900" indent="-342900" algn="l">
+              <a:lnSpc>
+                <a:spcPts val="2500"/>
+              </a:lnSpc>
+              <a:buSzPct val="100000"/>
+              <a:buChar char="•"/>
+            </a:pPr>
+            <a:r>
+              <a:rPr lang="en-US" sz="2800" dirty="0">
+                <a:solidFill>
+                  <a:srgbClr val="151617"/>
+                </a:solidFill>
+                <a:latin typeface="Inconsolata" pitchFamily="34" charset="0"/>
+                <a:ea typeface="Inconsolata" pitchFamily="34" charset="-122"/>
+                <a:cs typeface="Inconsolata" pitchFamily="34" charset="-120"/>
+              </a:rPr>
+              <a:t>Database: MySQL.</a:t>
+            </a:r>
+          </a:p>
+          <a:p>
+            <a:pPr marL="342900" indent="-342900" algn="l">
+              <a:lnSpc>
+                <a:spcPts val="2500"/>
+              </a:lnSpc>
+              <a:buSzPct val="100000"/>
+              <a:buChar char="•"/>
+            </a:pPr>
+            <a:endParaRPr lang="en-US" sz="2800" dirty="0"/>
+          </a:p>
+          <a:p>
+            <a:pPr marL="342900" indent="-342900" algn="l">
+              <a:lnSpc>
+                <a:spcPts val="2500"/>
+              </a:lnSpc>
+              <a:buSzPct val="100000"/>
+              <a:buChar char="•"/>
+            </a:pPr>
+            <a:r>
+              <a:rPr lang="en-US" sz="2800" dirty="0">
+                <a:solidFill>
+                  <a:srgbClr val="151617"/>
+                </a:solidFill>
+                <a:latin typeface="Inconsolata" pitchFamily="34" charset="0"/>
+                <a:ea typeface="Inconsolata" pitchFamily="34" charset="-122"/>
+                <a:cs typeface="Inconsolata" pitchFamily="34" charset="-120"/>
+              </a:rPr>
+              <a:t>Frontend: HTML/CSS sederhana, template navbar terpisah untuk konsistensi UI.</a:t>
+            </a:r>
+          </a:p>
+          <a:p>
+            <a:pPr marL="342900" indent="-342900" algn="l">
+              <a:lnSpc>
+                <a:spcPts val="2500"/>
+              </a:lnSpc>
+              <a:buSzPct val="100000"/>
+              <a:buChar char="•"/>
+            </a:pPr>
+            <a:endParaRPr lang="en-US" sz="2800" dirty="0"/>
+          </a:p>
+          <a:p>
+            <a:pPr marL="342900" indent="-342900" algn="l">
+              <a:lnSpc>
+                <a:spcPts val="2500"/>
+              </a:lnSpc>
+              <a:buSzPct val="100000"/>
+              <a:buChar char="•"/>
+            </a:pPr>
+            <a:r>
+              <a:rPr lang="en-US" sz="2800" dirty="0">
+                <a:solidFill>
+                  <a:srgbClr val="151617"/>
+                </a:solidFill>
+                <a:latin typeface="Inconsolata" pitchFamily="34" charset="0"/>
+                <a:ea typeface="Inconsolata" pitchFamily="34" charset="-122"/>
+                <a:cs typeface="Inconsolata" pitchFamily="34" charset="-120"/>
+              </a:rPr>
+              <a:t>File upload: digunakan untuk foto bukti aspirasi dan progres perbaikan.</a:t>
+            </a:r>
+            <a:endParaRPr lang="en-US" sz="2800" dirty="0"/>
+          </a:p>
+        </p:txBody>
+      </p:sp>
+      <p:grpSp>
+        <p:nvGrpSpPr>
+          <p:cNvPr id="4" name="Group 3">
+            <a:extLst>
+              <a:ext uri="{FF2B5EF4-FFF2-40B4-BE49-F238E27FC236}">
+                <a16:creationId xmlns:a16="http://schemas.microsoft.com/office/drawing/2014/main" id="{907910DD-3CE6-08C8-F5A4-C05B33310656}"/>
+              </a:ext>
+            </a:extLst>
+          </p:cNvPr>
+          <p:cNvGrpSpPr/>
+          <p:nvPr/>
+        </p:nvGrpSpPr>
+        <p:grpSpPr>
+          <a:xfrm>
+            <a:off x="12680321" y="6570877"/>
+            <a:ext cx="1894787" cy="1515015"/>
+            <a:chOff x="12600860" y="6601810"/>
+            <a:chExt cx="1894787" cy="1515015"/>
+          </a:xfrm>
+        </p:grpSpPr>
+        <p:pic>
+          <p:nvPicPr>
+            <p:cNvPr id="5" name="Picture 4">
+              <a:extLst>
+                <a:ext uri="{FF2B5EF4-FFF2-40B4-BE49-F238E27FC236}">
+                  <a16:creationId xmlns:a16="http://schemas.microsoft.com/office/drawing/2014/main" id="{C144965A-170C-EB82-90B7-4B210969A548}"/>
+                </a:ext>
+              </a:extLst>
+            </p:cNvPr>
+            <p:cNvPicPr>
+              <a:picLocks noChangeAspect="1"/>
+            </p:cNvPicPr>
+            <p:nvPr/>
+          </p:nvPicPr>
+          <p:blipFill>
+            <a:blip r:embed="rId3"/>
+            <a:stretch>
+              <a:fillRect/>
+            </a:stretch>
+          </p:blipFill>
+          <p:spPr>
+            <a:xfrm>
+              <a:off x="12928350" y="6601810"/>
+              <a:ext cx="1239806" cy="1239806"/>
+            </a:xfrm>
+            <a:prstGeom prst="rect">
+              <a:avLst/>
+            </a:prstGeom>
+          </p:spPr>
+        </p:pic>
+        <p:sp>
+          <p:nvSpPr>
+            <p:cNvPr id="6" name="Rectangle 5">
+              <a:extLst>
+                <a:ext uri="{FF2B5EF4-FFF2-40B4-BE49-F238E27FC236}">
+                  <a16:creationId xmlns:a16="http://schemas.microsoft.com/office/drawing/2014/main" id="{3520C9B8-7A52-3E6D-6AD2-556F4BFE079D}"/>
+                </a:ext>
+              </a:extLst>
+            </p:cNvPr>
+            <p:cNvSpPr/>
+            <p:nvPr/>
+          </p:nvSpPr>
+          <p:spPr>
+            <a:xfrm>
+              <a:off x="12600860" y="7737100"/>
+              <a:ext cx="1894787" cy="379725"/>
+            </a:xfrm>
+            <a:prstGeom prst="rect">
+              <a:avLst/>
+            </a:prstGeom>
+          </p:spPr>
+          <p:style>
+            <a:lnRef idx="2">
+              <a:schemeClr val="accent1">
+                <a:shade val="15000"/>
+              </a:schemeClr>
+            </a:lnRef>
+            <a:fillRef idx="1001">
+              <a:schemeClr val="lt2"/>
+            </a:fillRef>
+            <a:effectRef idx="0">
+              <a:schemeClr val="accent1"/>
+            </a:effectRef>
+            <a:fontRef idx="minor">
+              <a:schemeClr val="lt1"/>
+            </a:fontRef>
+          </p:style>
+          <p:txBody>
+            <a:bodyPr rtlCol="0" anchor="ctr"/>
+            <a:lstStyle>
+              <a:defPPr>
+                <a:defRPr lang="en-US"/>
+              </a:defPPr>
+              <a:lvl1pPr marL="0" algn="l" defTabSz="914400" rtl="0" eaLnBrk="1" latinLnBrk="0" hangingPunct="1">
+                <a:defRPr sz="1800" kern="1200">
+                  <a:solidFill>
+                    <a:schemeClr val="lt1"/>
+                  </a:solidFill>
+                  <a:latin typeface="+mn-lt"/>
+                  <a:ea typeface="+mn-ea"/>
+                  <a:cs typeface="+mn-cs"/>
+                </a:defRPr>
+              </a:lvl1pPr>
+              <a:lvl2pPr marL="457200" algn="l" defTabSz="914400" rtl="0" eaLnBrk="1" latinLnBrk="0" hangingPunct="1">
+                <a:defRPr sz="1800" kern="1200">
+                  <a:solidFill>
+                    <a:schemeClr val="lt1"/>
+                  </a:solidFill>
+                  <a:latin typeface="+mn-lt"/>
+                  <a:ea typeface="+mn-ea"/>
+                  <a:cs typeface="+mn-cs"/>
+                </a:defRPr>
+              </a:lvl2pPr>
+              <a:lvl3pPr marL="914400" algn="l" defTabSz="914400" rtl="0" eaLnBrk="1" latinLnBrk="0" hangingPunct="1">
+                <a:defRPr sz="1800" kern="1200">
+                  <a:solidFill>
+                    <a:schemeClr val="lt1"/>
+                  </a:solidFill>
+                  <a:latin typeface="+mn-lt"/>
+                  <a:ea typeface="+mn-ea"/>
+                  <a:cs typeface="+mn-cs"/>
+                </a:defRPr>
+              </a:lvl3pPr>
+              <a:lvl4pPr marL="1371600" algn="l" defTabSz="914400" rtl="0" eaLnBrk="1" latinLnBrk="0" hangingPunct="1">
+                <a:defRPr sz="1800" kern="1200">
+                  <a:solidFill>
+                    <a:schemeClr val="lt1"/>
+                  </a:solidFill>
+                  <a:latin typeface="+mn-lt"/>
+                  <a:ea typeface="+mn-ea"/>
+                  <a:cs typeface="+mn-cs"/>
+                </a:defRPr>
+              </a:lvl4pPr>
+              <a:lvl5pPr marL="1828800" algn="l" defTabSz="914400" rtl="0" eaLnBrk="1" latinLnBrk="0" hangingPunct="1">
+                <a:defRPr sz="1800" kern="1200">
+                  <a:solidFill>
+                    <a:schemeClr val="lt1"/>
+                  </a:solidFill>
+                  <a:latin typeface="+mn-lt"/>
+                  <a:ea typeface="+mn-ea"/>
+                  <a:cs typeface="+mn-cs"/>
+                </a:defRPr>
+              </a:lvl5pPr>
+              <a:lvl6pPr marL="2286000" algn="l" defTabSz="914400" rtl="0" eaLnBrk="1" latinLnBrk="0" hangingPunct="1">
+                <a:defRPr sz="1800" kern="1200">
+                  <a:solidFill>
+                    <a:schemeClr val="lt1"/>
+                  </a:solidFill>
+                  <a:latin typeface="+mn-lt"/>
+                  <a:ea typeface="+mn-ea"/>
+                  <a:cs typeface="+mn-cs"/>
+                </a:defRPr>
+              </a:lvl6pPr>
+              <a:lvl7pPr marL="2743200" algn="l" defTabSz="914400" rtl="0" eaLnBrk="1" latinLnBrk="0" hangingPunct="1">
+                <a:defRPr sz="1800" kern="1200">
+                  <a:solidFill>
+                    <a:schemeClr val="lt1"/>
+                  </a:solidFill>
+                  <a:latin typeface="+mn-lt"/>
+                  <a:ea typeface="+mn-ea"/>
+                  <a:cs typeface="+mn-cs"/>
+                </a:defRPr>
+              </a:lvl7pPr>
+              <a:lvl8pPr marL="3200400" algn="l" defTabSz="914400" rtl="0" eaLnBrk="1" latinLnBrk="0" hangingPunct="1">
+                <a:defRPr sz="1800" kern="1200">
+                  <a:solidFill>
+                    <a:schemeClr val="lt1"/>
+                  </a:solidFill>
+                  <a:latin typeface="+mn-lt"/>
+                  <a:ea typeface="+mn-ea"/>
+                  <a:cs typeface="+mn-cs"/>
+                </a:defRPr>
+              </a:lvl8pPr>
+              <a:lvl9pPr marL="3657600" algn="l" defTabSz="914400" rtl="0" eaLnBrk="1" latinLnBrk="0" hangingPunct="1">
+                <a:defRPr sz="1800" kern="1200">
+                  <a:solidFill>
+                    <a:schemeClr val="lt1"/>
+                  </a:solidFill>
+                  <a:latin typeface="+mn-lt"/>
+                  <a:ea typeface="+mn-ea"/>
+                  <a:cs typeface="+mn-cs"/>
+                </a:defRPr>
+              </a:lvl9pPr>
+            </a:lstStyle>
+            <a:p>
+              <a:pPr algn="ctr"/>
+              <a:r>
+                <a:rPr lang="en-US" b="1" dirty="0" err="1">
+                  <a:solidFill>
+                    <a:schemeClr val="tx1"/>
+                  </a:solidFill>
+                </a:rPr>
+                <a:t>Kelompok</a:t>
+              </a:r>
+              <a:r>
+                <a:rPr lang="en-US" b="1" dirty="0">
+                  <a:solidFill>
+                    <a:schemeClr val="tx1"/>
+                  </a:solidFill>
+                </a:rPr>
+                <a:t> 6</a:t>
+              </a:r>
+            </a:p>
+          </p:txBody>
+        </p:sp>
+      </p:grpSp>
+    </p:spTree>
+  </p:cSld>
+  <p:clrMapOvr>
+    <a:masterClrMapping/>
+  </p:clrMapOvr>
+</p:sld>
+</file>
+
+<file path=ppt/slides/slide11.xml><?xml version="1.0" encoding="utf-8"?>
+<p:sld xmlns:a="http://schemas.openxmlformats.org/drawingml/2006/main" xmlns:r="http://schemas.openxmlformats.org/officeDocument/2006/relationships" xmlns:p="http://schemas.openxmlformats.org/presentationml/2006/main">
   <p:cSld name="Slide 10">
     <p:spTree>
       <p:nvGrpSpPr>
@@ -6028,6 +6595,361 @@
 
 <file path=ppt/slides/slide6.xml><?xml version="1.0" encoding="utf-8"?>
 <p:sld xmlns:a="http://schemas.openxmlformats.org/drawingml/2006/main" xmlns:r="http://schemas.openxmlformats.org/officeDocument/2006/relationships" xmlns:p="http://schemas.openxmlformats.org/presentationml/2006/main">
+  <p:cSld>
+    <p:spTree>
+      <p:nvGrpSpPr>
+        <p:cNvPr id="1" name="">
+          <a:extLst>
+            <a:ext uri="{FF2B5EF4-FFF2-40B4-BE49-F238E27FC236}">
+              <a16:creationId xmlns:a16="http://schemas.microsoft.com/office/drawing/2014/main" id="{88DAF0E8-26C8-0A33-60CA-217FF84B23C5}"/>
+            </a:ext>
+          </a:extLst>
+        </p:cNvPr>
+        <p:cNvGrpSpPr/>
+        <p:nvPr/>
+      </p:nvGrpSpPr>
+      <p:grpSpPr>
+        <a:xfrm>
+          <a:off x="0" y="0"/>
+          <a:ext cx="0" cy="0"/>
+          <a:chOff x="0" y="0"/>
+          <a:chExt cx="0" cy="0"/>
+        </a:xfrm>
+      </p:grpSpPr>
+      <p:sp>
+        <p:nvSpPr>
+          <p:cNvPr id="2" name="Text 0">
+            <a:extLst>
+              <a:ext uri="{FF2B5EF4-FFF2-40B4-BE49-F238E27FC236}">
+                <a16:creationId xmlns:a16="http://schemas.microsoft.com/office/drawing/2014/main" id="{9FBF82DF-CC8D-3E03-F58B-4D284A50561A}"/>
+              </a:ext>
+            </a:extLst>
+          </p:cNvPr>
+          <p:cNvSpPr/>
+          <p:nvPr/>
+        </p:nvSpPr>
+        <p:spPr>
+          <a:xfrm>
+            <a:off x="1068348" y="217931"/>
+            <a:ext cx="4062889" cy="496133"/>
+          </a:xfrm>
+          <a:prstGeom prst="rect">
+            <a:avLst/>
+          </a:prstGeom>
+          <a:noFill/>
+          <a:ln/>
+        </p:spPr>
+        <p:txBody>
+          <a:bodyPr wrap="none" lIns="0" tIns="0" rIns="0" bIns="0" rtlCol="0" anchor="t"/>
+          <a:lstStyle/>
+          <a:p>
+            <a:pPr marL="0" indent="0" algn="l">
+              <a:lnSpc>
+                <a:spcPts val="3900"/>
+              </a:lnSpc>
+              <a:buNone/>
+            </a:pPr>
+            <a:r>
+              <a:rPr lang="en-US" sz="3100" b="1" dirty="0">
+                <a:solidFill>
+                  <a:srgbClr val="151617"/>
+                </a:solidFill>
+                <a:latin typeface="Montserrat Black" pitchFamily="34" charset="0"/>
+              </a:rPr>
+              <a:t>SKEMA DATABASE</a:t>
+            </a:r>
+            <a:endParaRPr lang="en-US" sz="3100" dirty="0"/>
+          </a:p>
+        </p:txBody>
+      </p:sp>
+      <p:sp>
+        <p:nvSpPr>
+          <p:cNvPr id="9" name="Text 6">
+            <a:extLst>
+              <a:ext uri="{FF2B5EF4-FFF2-40B4-BE49-F238E27FC236}">
+                <a16:creationId xmlns:a16="http://schemas.microsoft.com/office/drawing/2014/main" id="{9BC43FC8-A260-375C-F015-AE73F912237C}"/>
+              </a:ext>
+            </a:extLst>
+          </p:cNvPr>
+          <p:cNvSpPr/>
+          <p:nvPr/>
+        </p:nvSpPr>
+        <p:spPr>
+          <a:xfrm>
+            <a:off x="1438513" y="5576888"/>
+            <a:ext cx="12199739" cy="317540"/>
+          </a:xfrm>
+          <a:prstGeom prst="rect">
+            <a:avLst/>
+          </a:prstGeom>
+          <a:noFill/>
+          <a:ln/>
+        </p:spPr>
+        <p:txBody>
+          <a:bodyPr wrap="none" lIns="0" tIns="0" rIns="0" bIns="0" rtlCol="0" anchor="t"/>
+          <a:lstStyle/>
+          <a:p>
+            <a:pPr marL="0" indent="0" algn="l">
+              <a:lnSpc>
+                <a:spcPts val="2500"/>
+              </a:lnSpc>
+              <a:buNone/>
+            </a:pPr>
+            <a:endParaRPr lang="en-US" sz="1550" dirty="0"/>
+          </a:p>
+        </p:txBody>
+      </p:sp>
+      <p:grpSp>
+        <p:nvGrpSpPr>
+          <p:cNvPr id="10" name="Group 9">
+            <a:extLst>
+              <a:ext uri="{FF2B5EF4-FFF2-40B4-BE49-F238E27FC236}">
+                <a16:creationId xmlns:a16="http://schemas.microsoft.com/office/drawing/2014/main" id="{24F0BE2B-CE74-ABF1-8E54-C9EDDE88BEED}"/>
+              </a:ext>
+            </a:extLst>
+          </p:cNvPr>
+          <p:cNvGrpSpPr/>
+          <p:nvPr/>
+        </p:nvGrpSpPr>
+        <p:grpSpPr>
+          <a:xfrm>
+            <a:off x="12782550" y="6781800"/>
+            <a:ext cx="1803095" cy="1323902"/>
+            <a:chOff x="12600860" y="6601810"/>
+            <a:chExt cx="1894787" cy="1515015"/>
+          </a:xfrm>
+        </p:grpSpPr>
+        <p:pic>
+          <p:nvPicPr>
+            <p:cNvPr id="11" name="Picture 10">
+              <a:extLst>
+                <a:ext uri="{FF2B5EF4-FFF2-40B4-BE49-F238E27FC236}">
+                  <a16:creationId xmlns:a16="http://schemas.microsoft.com/office/drawing/2014/main" id="{FC73052F-0AD0-74B0-E6B9-D507A20381CE}"/>
+                </a:ext>
+              </a:extLst>
+            </p:cNvPr>
+            <p:cNvPicPr>
+              <a:picLocks noChangeAspect="1"/>
+            </p:cNvPicPr>
+            <p:nvPr/>
+          </p:nvPicPr>
+          <p:blipFill>
+            <a:blip r:embed="rId3"/>
+            <a:stretch>
+              <a:fillRect/>
+            </a:stretch>
+          </p:blipFill>
+          <p:spPr>
+            <a:xfrm>
+              <a:off x="12928350" y="6601810"/>
+              <a:ext cx="1239806" cy="1239806"/>
+            </a:xfrm>
+            <a:prstGeom prst="rect">
+              <a:avLst/>
+            </a:prstGeom>
+          </p:spPr>
+        </p:pic>
+        <p:sp>
+          <p:nvSpPr>
+            <p:cNvPr id="12" name="Rectangle 11">
+              <a:extLst>
+                <a:ext uri="{FF2B5EF4-FFF2-40B4-BE49-F238E27FC236}">
+                  <a16:creationId xmlns:a16="http://schemas.microsoft.com/office/drawing/2014/main" id="{44FBA800-39DD-FA59-1F04-B0D0E9C1D6B8}"/>
+                </a:ext>
+              </a:extLst>
+            </p:cNvPr>
+            <p:cNvSpPr/>
+            <p:nvPr/>
+          </p:nvSpPr>
+          <p:spPr>
+            <a:xfrm>
+              <a:off x="12600860" y="7737100"/>
+              <a:ext cx="1894787" cy="379725"/>
+            </a:xfrm>
+            <a:prstGeom prst="rect">
+              <a:avLst/>
+            </a:prstGeom>
+          </p:spPr>
+          <p:style>
+            <a:lnRef idx="2">
+              <a:schemeClr val="accent1">
+                <a:shade val="15000"/>
+              </a:schemeClr>
+            </a:lnRef>
+            <a:fillRef idx="1001">
+              <a:schemeClr val="lt2"/>
+            </a:fillRef>
+            <a:effectRef idx="0">
+              <a:schemeClr val="accent1"/>
+            </a:effectRef>
+            <a:fontRef idx="minor">
+              <a:schemeClr val="lt1"/>
+            </a:fontRef>
+          </p:style>
+          <p:txBody>
+            <a:bodyPr rtlCol="0" anchor="ctr"/>
+            <a:lstStyle>
+              <a:defPPr>
+                <a:defRPr lang="en-US"/>
+              </a:defPPr>
+              <a:lvl1pPr marL="0" algn="l" defTabSz="914400" rtl="0" eaLnBrk="1" latinLnBrk="0" hangingPunct="1">
+                <a:defRPr sz="1800" kern="1200">
+                  <a:solidFill>
+                    <a:schemeClr val="lt1"/>
+                  </a:solidFill>
+                  <a:latin typeface="+mn-lt"/>
+                  <a:ea typeface="+mn-ea"/>
+                  <a:cs typeface="+mn-cs"/>
+                </a:defRPr>
+              </a:lvl1pPr>
+              <a:lvl2pPr marL="457200" algn="l" defTabSz="914400" rtl="0" eaLnBrk="1" latinLnBrk="0" hangingPunct="1">
+                <a:defRPr sz="1800" kern="1200">
+                  <a:solidFill>
+                    <a:schemeClr val="lt1"/>
+                  </a:solidFill>
+                  <a:latin typeface="+mn-lt"/>
+                  <a:ea typeface="+mn-ea"/>
+                  <a:cs typeface="+mn-cs"/>
+                </a:defRPr>
+              </a:lvl2pPr>
+              <a:lvl3pPr marL="914400" algn="l" defTabSz="914400" rtl="0" eaLnBrk="1" latinLnBrk="0" hangingPunct="1">
+                <a:defRPr sz="1800" kern="1200">
+                  <a:solidFill>
+                    <a:schemeClr val="lt1"/>
+                  </a:solidFill>
+                  <a:latin typeface="+mn-lt"/>
+                  <a:ea typeface="+mn-ea"/>
+                  <a:cs typeface="+mn-cs"/>
+                </a:defRPr>
+              </a:lvl3pPr>
+              <a:lvl4pPr marL="1371600" algn="l" defTabSz="914400" rtl="0" eaLnBrk="1" latinLnBrk="0" hangingPunct="1">
+                <a:defRPr sz="1800" kern="1200">
+                  <a:solidFill>
+                    <a:schemeClr val="lt1"/>
+                  </a:solidFill>
+                  <a:latin typeface="+mn-lt"/>
+                  <a:ea typeface="+mn-ea"/>
+                  <a:cs typeface="+mn-cs"/>
+                </a:defRPr>
+              </a:lvl4pPr>
+              <a:lvl5pPr marL="1828800" algn="l" defTabSz="914400" rtl="0" eaLnBrk="1" latinLnBrk="0" hangingPunct="1">
+                <a:defRPr sz="1800" kern="1200">
+                  <a:solidFill>
+                    <a:schemeClr val="lt1"/>
+                  </a:solidFill>
+                  <a:latin typeface="+mn-lt"/>
+                  <a:ea typeface="+mn-ea"/>
+                  <a:cs typeface="+mn-cs"/>
+                </a:defRPr>
+              </a:lvl5pPr>
+              <a:lvl6pPr marL="2286000" algn="l" defTabSz="914400" rtl="0" eaLnBrk="1" latinLnBrk="0" hangingPunct="1">
+                <a:defRPr sz="1800" kern="1200">
+                  <a:solidFill>
+                    <a:schemeClr val="lt1"/>
+                  </a:solidFill>
+                  <a:latin typeface="+mn-lt"/>
+                  <a:ea typeface="+mn-ea"/>
+                  <a:cs typeface="+mn-cs"/>
+                </a:defRPr>
+              </a:lvl6pPr>
+              <a:lvl7pPr marL="2743200" algn="l" defTabSz="914400" rtl="0" eaLnBrk="1" latinLnBrk="0" hangingPunct="1">
+                <a:defRPr sz="1800" kern="1200">
+                  <a:solidFill>
+                    <a:schemeClr val="lt1"/>
+                  </a:solidFill>
+                  <a:latin typeface="+mn-lt"/>
+                  <a:ea typeface="+mn-ea"/>
+                  <a:cs typeface="+mn-cs"/>
+                </a:defRPr>
+              </a:lvl7pPr>
+              <a:lvl8pPr marL="3200400" algn="l" defTabSz="914400" rtl="0" eaLnBrk="1" latinLnBrk="0" hangingPunct="1">
+                <a:defRPr sz="1800" kern="1200">
+                  <a:solidFill>
+                    <a:schemeClr val="lt1"/>
+                  </a:solidFill>
+                  <a:latin typeface="+mn-lt"/>
+                  <a:ea typeface="+mn-ea"/>
+                  <a:cs typeface="+mn-cs"/>
+                </a:defRPr>
+              </a:lvl8pPr>
+              <a:lvl9pPr marL="3657600" algn="l" defTabSz="914400" rtl="0" eaLnBrk="1" latinLnBrk="0" hangingPunct="1">
+                <a:defRPr sz="1800" kern="1200">
+                  <a:solidFill>
+                    <a:schemeClr val="lt1"/>
+                  </a:solidFill>
+                  <a:latin typeface="+mn-lt"/>
+                  <a:ea typeface="+mn-ea"/>
+                  <a:cs typeface="+mn-cs"/>
+                </a:defRPr>
+              </a:lvl9pPr>
+            </a:lstStyle>
+            <a:p>
+              <a:pPr algn="ctr"/>
+              <a:r>
+                <a:rPr lang="en-US" b="1" dirty="0" err="1">
+                  <a:solidFill>
+                    <a:schemeClr val="tx1"/>
+                  </a:solidFill>
+                </a:rPr>
+                <a:t>Kelompok</a:t>
+              </a:r>
+              <a:r>
+                <a:rPr lang="en-US" b="1" dirty="0">
+                  <a:solidFill>
+                    <a:schemeClr val="tx1"/>
+                  </a:solidFill>
+                </a:rPr>
+                <a:t> 6</a:t>
+              </a:r>
+            </a:p>
+          </p:txBody>
+        </p:sp>
+      </p:grpSp>
+      <p:pic>
+        <p:nvPicPr>
+          <p:cNvPr id="8" name="Picture 7">
+            <a:extLst>
+              <a:ext uri="{FF2B5EF4-FFF2-40B4-BE49-F238E27FC236}">
+                <a16:creationId xmlns:a16="http://schemas.microsoft.com/office/drawing/2014/main" id="{882B9556-F515-C465-61A4-38B3F506A4F9}"/>
+              </a:ext>
+            </a:extLst>
+          </p:cNvPr>
+          <p:cNvPicPr>
+            <a:picLocks noChangeAspect="1"/>
+          </p:cNvPicPr>
+          <p:nvPr/>
+        </p:nvPicPr>
+        <p:blipFill>
+          <a:blip r:embed="rId4"/>
+          <a:stretch>
+            <a:fillRect/>
+          </a:stretch>
+        </p:blipFill>
+        <p:spPr>
+          <a:xfrm>
+            <a:off x="1689089" y="714064"/>
+            <a:ext cx="11252221" cy="6230340"/>
+          </a:xfrm>
+          <a:prstGeom prst="rect">
+            <a:avLst/>
+          </a:prstGeom>
+        </p:spPr>
+      </p:pic>
+    </p:spTree>
+    <p:extLst>
+      <p:ext uri="{BB962C8B-B14F-4D97-AF65-F5344CB8AC3E}">
+        <p14:creationId xmlns:p14="http://schemas.microsoft.com/office/powerpoint/2010/main" val="992045893"/>
+      </p:ext>
+    </p:extLst>
+  </p:cSld>
+  <p:clrMapOvr>
+    <a:masterClrMapping/>
+  </p:clrMapOvr>
+</p:sld>
+</file>
+
+<file path=ppt/slides/slide7.xml><?xml version="1.0" encoding="utf-8"?>
+<p:sld xmlns:a="http://schemas.openxmlformats.org/drawingml/2006/main" xmlns:r="http://schemas.openxmlformats.org/officeDocument/2006/relationships" xmlns:p="http://schemas.openxmlformats.org/presentationml/2006/main">
   <p:cSld name="Slide 6">
     <p:spTree>
       <p:nvGrpSpPr>
@@ -6869,7 +7791,7 @@
 </p:sld>
 </file>
 
-<file path=ppt/slides/slide7.xml><?xml version="1.0" encoding="utf-8"?>
+<file path=ppt/slides/slide8.xml><?xml version="1.0" encoding="utf-8"?>
 <p:sld xmlns:a="http://schemas.openxmlformats.org/drawingml/2006/main" xmlns:r="http://schemas.openxmlformats.org/officeDocument/2006/relationships" xmlns:p="http://schemas.openxmlformats.org/presentationml/2006/main">
   <p:cSld name="Slide 7">
     <p:spTree>
@@ -7439,7 +8361,7 @@
 </p:sld>
 </file>
 
-<file path=ppt/slides/slide8.xml><?xml version="1.0" encoding="utf-8"?>
+<file path=ppt/slides/slide9.xml><?xml version="1.0" encoding="utf-8"?>
 <p:sld xmlns:a="http://schemas.openxmlformats.org/drawingml/2006/main" xmlns:r="http://schemas.openxmlformats.org/officeDocument/2006/relationships" xmlns:p="http://schemas.openxmlformats.org/presentationml/2006/main">
   <p:cSld name="Slide 8">
     <p:spTree>
@@ -7933,464 +8855,6 @@
               <a:extLst>
                 <a:ext uri="{FF2B5EF4-FFF2-40B4-BE49-F238E27FC236}">
                   <a16:creationId xmlns:a16="http://schemas.microsoft.com/office/drawing/2014/main" id="{FE236555-6DA2-181D-904C-5DFA93D26FEE}"/>
-                </a:ext>
-              </a:extLst>
-            </p:cNvPr>
-            <p:cNvSpPr/>
-            <p:nvPr/>
-          </p:nvSpPr>
-          <p:spPr>
-            <a:xfrm>
-              <a:off x="12600860" y="7737100"/>
-              <a:ext cx="1894787" cy="379725"/>
-            </a:xfrm>
-            <a:prstGeom prst="rect">
-              <a:avLst/>
-            </a:prstGeom>
-          </p:spPr>
-          <p:style>
-            <a:lnRef idx="2">
-              <a:schemeClr val="accent1">
-                <a:shade val="15000"/>
-              </a:schemeClr>
-            </a:lnRef>
-            <a:fillRef idx="1001">
-              <a:schemeClr val="lt2"/>
-            </a:fillRef>
-            <a:effectRef idx="0">
-              <a:schemeClr val="accent1"/>
-            </a:effectRef>
-            <a:fontRef idx="minor">
-              <a:schemeClr val="lt1"/>
-            </a:fontRef>
-          </p:style>
-          <p:txBody>
-            <a:bodyPr rtlCol="0" anchor="ctr"/>
-            <a:lstStyle>
-              <a:defPPr>
-                <a:defRPr lang="en-US"/>
-              </a:defPPr>
-              <a:lvl1pPr marL="0" algn="l" defTabSz="914400" rtl="0" eaLnBrk="1" latinLnBrk="0" hangingPunct="1">
-                <a:defRPr sz="1800" kern="1200">
-                  <a:solidFill>
-                    <a:schemeClr val="lt1"/>
-                  </a:solidFill>
-                  <a:latin typeface="+mn-lt"/>
-                  <a:ea typeface="+mn-ea"/>
-                  <a:cs typeface="+mn-cs"/>
-                </a:defRPr>
-              </a:lvl1pPr>
-              <a:lvl2pPr marL="457200" algn="l" defTabSz="914400" rtl="0" eaLnBrk="1" latinLnBrk="0" hangingPunct="1">
-                <a:defRPr sz="1800" kern="1200">
-                  <a:solidFill>
-                    <a:schemeClr val="lt1"/>
-                  </a:solidFill>
-                  <a:latin typeface="+mn-lt"/>
-                  <a:ea typeface="+mn-ea"/>
-                  <a:cs typeface="+mn-cs"/>
-                </a:defRPr>
-              </a:lvl2pPr>
-              <a:lvl3pPr marL="914400" algn="l" defTabSz="914400" rtl="0" eaLnBrk="1" latinLnBrk="0" hangingPunct="1">
-                <a:defRPr sz="1800" kern="1200">
-                  <a:solidFill>
-                    <a:schemeClr val="lt1"/>
-                  </a:solidFill>
-                  <a:latin typeface="+mn-lt"/>
-                  <a:ea typeface="+mn-ea"/>
-                  <a:cs typeface="+mn-cs"/>
-                </a:defRPr>
-              </a:lvl3pPr>
-              <a:lvl4pPr marL="1371600" algn="l" defTabSz="914400" rtl="0" eaLnBrk="1" latinLnBrk="0" hangingPunct="1">
-                <a:defRPr sz="1800" kern="1200">
-                  <a:solidFill>
-                    <a:schemeClr val="lt1"/>
-                  </a:solidFill>
-                  <a:latin typeface="+mn-lt"/>
-                  <a:ea typeface="+mn-ea"/>
-                  <a:cs typeface="+mn-cs"/>
-                </a:defRPr>
-              </a:lvl4pPr>
-              <a:lvl5pPr marL="1828800" algn="l" defTabSz="914400" rtl="0" eaLnBrk="1" latinLnBrk="0" hangingPunct="1">
-                <a:defRPr sz="1800" kern="1200">
-                  <a:solidFill>
-                    <a:schemeClr val="lt1"/>
-                  </a:solidFill>
-                  <a:latin typeface="+mn-lt"/>
-                  <a:ea typeface="+mn-ea"/>
-                  <a:cs typeface="+mn-cs"/>
-                </a:defRPr>
-              </a:lvl5pPr>
-              <a:lvl6pPr marL="2286000" algn="l" defTabSz="914400" rtl="0" eaLnBrk="1" latinLnBrk="0" hangingPunct="1">
-                <a:defRPr sz="1800" kern="1200">
-                  <a:solidFill>
-                    <a:schemeClr val="lt1"/>
-                  </a:solidFill>
-                  <a:latin typeface="+mn-lt"/>
-                  <a:ea typeface="+mn-ea"/>
-                  <a:cs typeface="+mn-cs"/>
-                </a:defRPr>
-              </a:lvl6pPr>
-              <a:lvl7pPr marL="2743200" algn="l" defTabSz="914400" rtl="0" eaLnBrk="1" latinLnBrk="0" hangingPunct="1">
-                <a:defRPr sz="1800" kern="1200">
-                  <a:solidFill>
-                    <a:schemeClr val="lt1"/>
-                  </a:solidFill>
-                  <a:latin typeface="+mn-lt"/>
-                  <a:ea typeface="+mn-ea"/>
-                  <a:cs typeface="+mn-cs"/>
-                </a:defRPr>
-              </a:lvl7pPr>
-              <a:lvl8pPr marL="3200400" algn="l" defTabSz="914400" rtl="0" eaLnBrk="1" latinLnBrk="0" hangingPunct="1">
-                <a:defRPr sz="1800" kern="1200">
-                  <a:solidFill>
-                    <a:schemeClr val="lt1"/>
-                  </a:solidFill>
-                  <a:latin typeface="+mn-lt"/>
-                  <a:ea typeface="+mn-ea"/>
-                  <a:cs typeface="+mn-cs"/>
-                </a:defRPr>
-              </a:lvl8pPr>
-              <a:lvl9pPr marL="3657600" algn="l" defTabSz="914400" rtl="0" eaLnBrk="1" latinLnBrk="0" hangingPunct="1">
-                <a:defRPr sz="1800" kern="1200">
-                  <a:solidFill>
-                    <a:schemeClr val="lt1"/>
-                  </a:solidFill>
-                  <a:latin typeface="+mn-lt"/>
-                  <a:ea typeface="+mn-ea"/>
-                  <a:cs typeface="+mn-cs"/>
-                </a:defRPr>
-              </a:lvl9pPr>
-            </a:lstStyle>
-            <a:p>
-              <a:pPr algn="ctr"/>
-              <a:r>
-                <a:rPr lang="en-US" b="1" dirty="0" err="1">
-                  <a:solidFill>
-                    <a:schemeClr val="tx1"/>
-                  </a:solidFill>
-                </a:rPr>
-                <a:t>Kelompok</a:t>
-              </a:r>
-              <a:r>
-                <a:rPr lang="en-US" b="1" dirty="0">
-                  <a:solidFill>
-                    <a:schemeClr val="tx1"/>
-                  </a:solidFill>
-                </a:rPr>
-                <a:t> 6</a:t>
-              </a:r>
-            </a:p>
-          </p:txBody>
-        </p:sp>
-      </p:grpSp>
-    </p:spTree>
-  </p:cSld>
-  <p:clrMapOvr>
-    <a:masterClrMapping/>
-  </p:clrMapOvr>
-</p:sld>
-</file>
-
-<file path=ppt/slides/slide9.xml><?xml version="1.0" encoding="utf-8"?>
-<p:sld xmlns:a="http://schemas.openxmlformats.org/drawingml/2006/main" xmlns:r="http://schemas.openxmlformats.org/officeDocument/2006/relationships" xmlns:p="http://schemas.openxmlformats.org/presentationml/2006/main">
-  <p:cSld name="Slide 9">
-    <p:spTree>
-      <p:nvGrpSpPr>
-        <p:cNvPr id="1" name=""/>
-        <p:cNvGrpSpPr/>
-        <p:nvPr/>
-      </p:nvGrpSpPr>
-      <p:grpSpPr>
-        <a:xfrm>
-          <a:off x="0" y="0"/>
-          <a:ext cx="0" cy="0"/>
-          <a:chOff x="0" y="0"/>
-          <a:chExt cx="0" cy="0"/>
-        </a:xfrm>
-      </p:grpSpPr>
-      <p:sp>
-        <p:nvSpPr>
-          <p:cNvPr id="2" name="Text 0"/>
-          <p:cNvSpPr/>
-          <p:nvPr/>
-        </p:nvSpPr>
-        <p:spPr>
-          <a:xfrm>
-            <a:off x="793790" y="1309162"/>
-            <a:ext cx="5795367" cy="496133"/>
-          </a:xfrm>
-          <a:prstGeom prst="rect">
-            <a:avLst/>
-          </a:prstGeom>
-          <a:noFill/>
-          <a:ln/>
-        </p:spPr>
-        <p:txBody>
-          <a:bodyPr wrap="none" lIns="0" tIns="0" rIns="0" bIns="0" rtlCol="0" anchor="t"/>
-          <a:lstStyle/>
-          <a:p>
-            <a:pPr marL="0" indent="0" algn="l">
-              <a:lnSpc>
-                <a:spcPts val="3900"/>
-              </a:lnSpc>
-              <a:buNone/>
-            </a:pPr>
-            <a:r>
-              <a:rPr lang="en-US" sz="3100" b="1" dirty="0">
-                <a:solidFill>
-                  <a:srgbClr val="151617"/>
-                </a:solidFill>
-                <a:latin typeface="Montserrat Black" pitchFamily="34" charset="0"/>
-                <a:ea typeface="Montserrat Black" pitchFamily="34" charset="-122"/>
-                <a:cs typeface="Montserrat Black" pitchFamily="34" charset="-120"/>
-              </a:rPr>
-              <a:t>Teknologi yang Digunakan</a:t>
-            </a:r>
-            <a:endParaRPr lang="en-US" sz="3100" dirty="0"/>
-          </a:p>
-        </p:txBody>
-      </p:sp>
-      <p:sp>
-        <p:nvSpPr>
-          <p:cNvPr id="3" name="Text 1"/>
-          <p:cNvSpPr/>
-          <p:nvPr/>
-        </p:nvSpPr>
-        <p:spPr>
-          <a:xfrm>
-            <a:off x="603315" y="2200822"/>
-            <a:ext cx="13129601" cy="3802410"/>
-          </a:xfrm>
-          <a:prstGeom prst="rect">
-            <a:avLst/>
-          </a:prstGeom>
-          <a:noFill/>
-          <a:ln/>
-        </p:spPr>
-        <p:txBody>
-          <a:bodyPr wrap="square" lIns="0" tIns="0" rIns="0" bIns="0" rtlCol="0" anchor="t"/>
-          <a:lstStyle/>
-          <a:p>
-            <a:pPr marL="342900" indent="-342900" algn="l">
-              <a:lnSpc>
-                <a:spcPts val="2500"/>
-              </a:lnSpc>
-              <a:buSzPct val="100000"/>
-              <a:buChar char="•"/>
-            </a:pPr>
-            <a:r>
-              <a:rPr lang="en-US" sz="2800" dirty="0">
-                <a:solidFill>
-                  <a:srgbClr val="151617"/>
-                </a:solidFill>
-                <a:latin typeface="Inconsolata" pitchFamily="34" charset="0"/>
-                <a:ea typeface="Inconsolata" pitchFamily="34" charset="-122"/>
-                <a:cs typeface="Inconsolata" pitchFamily="34" charset="-120"/>
-              </a:rPr>
-              <a:t>Backend: PHP (OOP) — struktur rapi, mudah dipelajari untuk siswa yang baru </a:t>
-            </a:r>
-            <a:r>
-              <a:rPr lang="en-US" sz="2800" dirty="0" err="1">
-                <a:solidFill>
-                  <a:srgbClr val="151617"/>
-                </a:solidFill>
-                <a:latin typeface="Inconsolata" pitchFamily="34" charset="0"/>
-                <a:ea typeface="Inconsolata" pitchFamily="34" charset="-122"/>
-                <a:cs typeface="Inconsolata" pitchFamily="34" charset="-120"/>
-              </a:rPr>
-              <a:t>belajar</a:t>
-            </a:r>
-            <a:r>
-              <a:rPr lang="en-US" sz="2800" dirty="0">
-                <a:solidFill>
-                  <a:srgbClr val="151617"/>
-                </a:solidFill>
-                <a:latin typeface="Inconsolata" pitchFamily="34" charset="0"/>
-                <a:ea typeface="Inconsolata" pitchFamily="34" charset="-122"/>
-                <a:cs typeface="Inconsolata" pitchFamily="34" charset="-120"/>
-              </a:rPr>
-              <a:t>.</a:t>
-            </a:r>
-          </a:p>
-          <a:p>
-            <a:pPr marL="342900" indent="-342900" algn="l">
-              <a:lnSpc>
-                <a:spcPts val="2500"/>
-              </a:lnSpc>
-              <a:buSzPct val="100000"/>
-              <a:buChar char="•"/>
-            </a:pPr>
-            <a:endParaRPr lang="en-US" sz="2800" dirty="0"/>
-          </a:p>
-          <a:p>
-            <a:pPr marL="342900" indent="-342900" algn="l">
-              <a:lnSpc>
-                <a:spcPts val="2500"/>
-              </a:lnSpc>
-              <a:buSzPct val="100000"/>
-              <a:buChar char="•"/>
-            </a:pPr>
-            <a:r>
-              <a:rPr lang="en-US" sz="2800" dirty="0">
-                <a:solidFill>
-                  <a:srgbClr val="151617"/>
-                </a:solidFill>
-                <a:latin typeface="Inconsolata" pitchFamily="34" charset="0"/>
-                <a:ea typeface="Inconsolata" pitchFamily="34" charset="-122"/>
-                <a:cs typeface="Inconsolata" pitchFamily="34" charset="-120"/>
-              </a:rPr>
-              <a:t>Arsitektur: MVC (Model-View-Controller) — memisahkan logika, tampilan, dan data.</a:t>
-            </a:r>
-          </a:p>
-          <a:p>
-            <a:pPr marL="342900" indent="-342900" algn="l">
-              <a:lnSpc>
-                <a:spcPts val="2500"/>
-              </a:lnSpc>
-              <a:buSzPct val="100000"/>
-              <a:buChar char="•"/>
-            </a:pPr>
-            <a:endParaRPr lang="en-US" sz="2800" dirty="0"/>
-          </a:p>
-          <a:p>
-            <a:pPr marL="342900" indent="-342900" algn="l">
-              <a:lnSpc>
-                <a:spcPts val="2500"/>
-              </a:lnSpc>
-              <a:buSzPct val="100000"/>
-              <a:buChar char="•"/>
-            </a:pPr>
-            <a:r>
-              <a:rPr lang="en-US" sz="2800" dirty="0">
-                <a:solidFill>
-                  <a:srgbClr val="151617"/>
-                </a:solidFill>
-                <a:latin typeface="Inconsolata" pitchFamily="34" charset="0"/>
-                <a:ea typeface="Inconsolata" pitchFamily="34" charset="-122"/>
-                <a:cs typeface="Inconsolata" pitchFamily="34" charset="-120"/>
-              </a:rPr>
-              <a:t>Database: MySQL.</a:t>
-            </a:r>
-          </a:p>
-          <a:p>
-            <a:pPr marL="342900" indent="-342900" algn="l">
-              <a:lnSpc>
-                <a:spcPts val="2500"/>
-              </a:lnSpc>
-              <a:buSzPct val="100000"/>
-              <a:buChar char="•"/>
-            </a:pPr>
-            <a:endParaRPr lang="en-US" sz="2800" dirty="0"/>
-          </a:p>
-          <a:p>
-            <a:pPr marL="342900" indent="-342900" algn="l">
-              <a:lnSpc>
-                <a:spcPts val="2500"/>
-              </a:lnSpc>
-              <a:buSzPct val="100000"/>
-              <a:buChar char="•"/>
-            </a:pPr>
-            <a:r>
-              <a:rPr lang="en-US" sz="2800" dirty="0">
-                <a:solidFill>
-                  <a:srgbClr val="151617"/>
-                </a:solidFill>
-                <a:latin typeface="Inconsolata" pitchFamily="34" charset="0"/>
-                <a:ea typeface="Inconsolata" pitchFamily="34" charset="-122"/>
-                <a:cs typeface="Inconsolata" pitchFamily="34" charset="-120"/>
-              </a:rPr>
-              <a:t>Frontend: HTML/CSS sederhana, template navbar terpisah untuk konsistensi UI.</a:t>
-            </a:r>
-          </a:p>
-          <a:p>
-            <a:pPr marL="342900" indent="-342900" algn="l">
-              <a:lnSpc>
-                <a:spcPts val="2500"/>
-              </a:lnSpc>
-              <a:buSzPct val="100000"/>
-              <a:buChar char="•"/>
-            </a:pPr>
-            <a:endParaRPr lang="en-US" sz="2800" dirty="0"/>
-          </a:p>
-          <a:p>
-            <a:pPr marL="342900" indent="-342900" algn="l">
-              <a:lnSpc>
-                <a:spcPts val="2500"/>
-              </a:lnSpc>
-              <a:buSzPct val="100000"/>
-              <a:buChar char="•"/>
-            </a:pPr>
-            <a:r>
-              <a:rPr lang="en-US" sz="2800" dirty="0">
-                <a:solidFill>
-                  <a:srgbClr val="151617"/>
-                </a:solidFill>
-                <a:latin typeface="Inconsolata" pitchFamily="34" charset="0"/>
-                <a:ea typeface="Inconsolata" pitchFamily="34" charset="-122"/>
-                <a:cs typeface="Inconsolata" pitchFamily="34" charset="-120"/>
-              </a:rPr>
-              <a:t>File upload: digunakan untuk foto bukti aspirasi dan progres perbaikan.</a:t>
-            </a:r>
-            <a:endParaRPr lang="en-US" sz="2800" dirty="0"/>
-          </a:p>
-        </p:txBody>
-      </p:sp>
-      <p:grpSp>
-        <p:nvGrpSpPr>
-          <p:cNvPr id="4" name="Group 3">
-            <a:extLst>
-              <a:ext uri="{FF2B5EF4-FFF2-40B4-BE49-F238E27FC236}">
-                <a16:creationId xmlns:a16="http://schemas.microsoft.com/office/drawing/2014/main" id="{907910DD-3CE6-08C8-F5A4-C05B33310656}"/>
-              </a:ext>
-            </a:extLst>
-          </p:cNvPr>
-          <p:cNvGrpSpPr/>
-          <p:nvPr/>
-        </p:nvGrpSpPr>
-        <p:grpSpPr>
-          <a:xfrm>
-            <a:off x="12680321" y="6570877"/>
-            <a:ext cx="1894787" cy="1515015"/>
-            <a:chOff x="12600860" y="6601810"/>
-            <a:chExt cx="1894787" cy="1515015"/>
-          </a:xfrm>
-        </p:grpSpPr>
-        <p:pic>
-          <p:nvPicPr>
-            <p:cNvPr id="5" name="Picture 4">
-              <a:extLst>
-                <a:ext uri="{FF2B5EF4-FFF2-40B4-BE49-F238E27FC236}">
-                  <a16:creationId xmlns:a16="http://schemas.microsoft.com/office/drawing/2014/main" id="{C144965A-170C-EB82-90B7-4B210969A548}"/>
-                </a:ext>
-              </a:extLst>
-            </p:cNvPr>
-            <p:cNvPicPr>
-              <a:picLocks noChangeAspect="1"/>
-            </p:cNvPicPr>
-            <p:nvPr/>
-          </p:nvPicPr>
-          <p:blipFill>
-            <a:blip r:embed="rId3"/>
-            <a:stretch>
-              <a:fillRect/>
-            </a:stretch>
-          </p:blipFill>
-          <p:spPr>
-            <a:xfrm>
-              <a:off x="12928350" y="6601810"/>
-              <a:ext cx="1239806" cy="1239806"/>
-            </a:xfrm>
-            <a:prstGeom prst="rect">
-              <a:avLst/>
-            </a:prstGeom>
-          </p:spPr>
-        </p:pic>
-        <p:sp>
-          <p:nvSpPr>
-            <p:cNvPr id="6" name="Rectangle 5">
-              <a:extLst>
-                <a:ext uri="{FF2B5EF4-FFF2-40B4-BE49-F238E27FC236}">
-                  <a16:creationId xmlns:a16="http://schemas.microsoft.com/office/drawing/2014/main" id="{3520C9B8-7A52-3E6D-6AD2-556F4BFE079D}"/>
                 </a:ext>
               </a:extLst>
             </p:cNvPr>

</xml_diff>